<commit_message>
docs: update team members in README and presentation (Slot: F1, Team: Team 13)
</commit_message>
<xml_diff>
--- a/docs/F1_Team13_PPT.pptx
+++ b/docs/F1_Team13_PPT.pptx
@@ -1903,7 +1903,7 @@
                   </a:schemeClr>
                 </a:solidFill>
               </a:rPr>
-              <a:t>NARNE ADITHYA HANUMAN</a:t>
+              <a:t>Narne Adithya Hanuman  |  G Sreemanth  |  V. Umika</a:t>
             </a:r>
           </a:p>
           <a:p>
@@ -1915,7 +1915,7 @@
                   </a:schemeClr>
                 </a:solidFill>
               </a:rPr>
-              <a:t>Slot: F1 | Team: 13</a:t>
+              <a:t>Slot: F1  |  Team: Team 13</a:t>
             </a:r>
           </a:p>
         </p:txBody>

</xml_diff>